<commit_message>
Change the slide 2 labels to plain English
Each box now says 1 thing in simple words.
The same name is used for the same item in all places.
All text stays at 14pt and fits the boxes.

Co-Authored-By: Claude Fable 5.1 <noreply@anthropic.com>
</commit_message>
<xml_diff>
--- a/progresss/20260901-comebine-slide2.pptx
+++ b/progresss/20260901-comebine-slide2.pptx
@@ -3084,7 +3084,7 @@
                 <a:cs typeface="Calibri"/>
                 <a:sym typeface="Calibri"/>
               </a:rPr>
-              <a:t>PRIOR KNOWLEDGE BASE</a:t>
+              <a:t>PRIOR KNOWLEDGE</a:t>
             </a:r>
             <a:endParaRPr b="0" i="0" sz="1400" u="none" cap="none" strike="noStrike">
               <a:solidFill>
@@ -3201,7 +3201,7 @@
                 <a:cs typeface="Calibri"/>
                 <a:sym typeface="Calibri"/>
               </a:rPr>
-              <a:t>Human Factors / Anatomy</a:t>
+              <a:t>Ear Anatomy and Human Factors</a:t>
             </a:r>
             <a:endParaRPr b="0" i="0" sz="1400" u="none" cap="none" strike="noStrike">
               <a:solidFill>
@@ -3318,7 +3318,7 @@
                 <a:cs typeface="Calibri"/>
                 <a:sym typeface="Calibri"/>
               </a:rPr>
-              <a:t>Commercial Benchmarks &amp; Patents</a:t>
+              <a:t>Market Products and Patents</a:t>
             </a:r>
             <a:endParaRPr b="0" i="0" sz="1400" u="none" cap="none" strike="noStrike">
               <a:solidFill>
@@ -3435,7 +3435,7 @@
                 <a:cs typeface="Calibri"/>
                 <a:sym typeface="Calibri"/>
               </a:rPr>
-              <a:t>Manufacturability Rules</a:t>
+              <a:t>Manufacturing Rules</a:t>
             </a:r>
             <a:endParaRPr b="0" i="0" sz="1400" u="none" cap="none" strike="noStrike">
               <a:solidFill>
@@ -3552,7 +3552,7 @@
                 <a:cs typeface="Calibri"/>
                 <a:sym typeface="Calibri"/>
               </a:rPr>
-              <a:t>Real Wearing Relationship</a:t>
+              <a:t>Real Wearing Data</a:t>
             </a:r>
             <a:endParaRPr b="0" i="0" sz="1400" u="none" cap="none" strike="noStrike">
               <a:solidFill>
@@ -3592,7 +3592,7 @@
                 <a:cs typeface="Calibri"/>
                 <a:sym typeface="Calibri"/>
               </a:rPr>
-              <a:t>Pose / Contact Distribution</a:t>
+              <a:t>Pose and Contact Areas</a:t>
             </a:r>
             <a:endParaRPr b="0" i="0" sz="1400" u="none" cap="none" strike="noStrike">
               <a:solidFill>
@@ -3772,7 +3772,7 @@
                 <a:cs typeface="Calibri"/>
                 <a:sym typeface="Calibri"/>
               </a:rPr>
-              <a:t>INPUT LAYER</a:t>
+              <a:t>INPUTS</a:t>
             </a:r>
             <a:endParaRPr b="0" i="0" sz="1400" u="none" cap="none" strike="noStrike">
               <a:solidFill>
@@ -4072,7 +4072,7 @@
                 <a:cs typeface="Calibri"/>
                 <a:sym typeface="Calibri"/>
               </a:rPr>
-              <a:t>3D Scan Data Sources</a:t>
+              <a:t>3D Scan Sources</a:t>
             </a:r>
             <a:endParaRPr b="0" i="0" sz="1400" u="none" cap="none" strike="noStrike">
               <a:solidFill>
@@ -4189,7 +4189,7 @@
                 <a:cs typeface="Calibri"/>
                 <a:sym typeface="Calibri"/>
               </a:rPr>
-              <a:t>Physical Product Scan</a:t>
+              <a:t>Commercial Earphone Scan</a:t>
             </a:r>
             <a:endParaRPr b="0" i="0" sz="1400" u="none" cap="none" strike="noStrike">
               <a:solidFill>
@@ -4229,7 +4229,7 @@
                 <a:cs typeface="Calibri"/>
                 <a:sym typeface="Calibri"/>
               </a:rPr>
-              <a:t>Existing Commercial Earphones</a:t>
+              <a:t>Products Already on Sale</a:t>
             </a:r>
             <a:endParaRPr b="0" i="0" sz="1400" u="none" cap="none" strike="noStrike">
               <a:solidFill>
@@ -4346,7 +4346,7 @@
                 <a:cs typeface="Calibri"/>
                 <a:sym typeface="Calibri"/>
               </a:rPr>
-              <a:t>Individual Ear Mold Scan</a:t>
+              <a:t>Ear Mold Scan</a:t>
             </a:r>
             <a:endParaRPr b="0" i="0" sz="1400" u="none" cap="none" strike="noStrike">
               <a:solidFill>
@@ -4386,7 +4386,7 @@
                 <a:cs typeface="Calibri"/>
                 <a:sym typeface="Calibri"/>
               </a:rPr>
-              <a:t>Team Members’ Ear Molds</a:t>
+              <a:t>Molds Taken from Team Members</a:t>
             </a:r>
             <a:endParaRPr b="0" i="0" sz="1400" u="none" cap="none" strike="noStrike">
               <a:solidFill>
@@ -4503,7 +4503,7 @@
                 <a:cs typeface="Calibri"/>
                 <a:sym typeface="Calibri"/>
               </a:rPr>
-              <a:t>Ear Mold + Worn Product Scan</a:t>
+              <a:t>Ear Mold + Earphone Scan</a:t>
             </a:r>
             <a:endParaRPr b="0" i="0" sz="1400" u="none" cap="none" strike="noStrike">
               <a:solidFill>
@@ -4543,7 +4543,7 @@
                 <a:cs typeface="Calibri"/>
                 <a:sym typeface="Calibri"/>
               </a:rPr>
-              <a:t>→ Real Wearing Pose</a:t>
+              <a:t>→ Gives the Real Wearing Pose</a:t>
             </a:r>
             <a:endParaRPr b="0" i="0" sz="1400" u="none" cap="none" strike="noStrike">
               <a:solidFill>
@@ -5098,7 +5098,7 @@
                 <a:cs typeface="Calibri"/>
                 <a:sym typeface="Calibri"/>
               </a:rPr>
-              <a:t>Requirements</a:t>
+              <a:t>Turns the</a:t>
             </a:r>
             <a:endParaRPr b="0" i="0" sz="1400" u="none" cap="none" strike="noStrike">
               <a:solidFill>
@@ -5138,7 +5138,7 @@
                 <a:cs typeface="Calibri"/>
                 <a:sym typeface="Calibri"/>
               </a:rPr>
-              <a:t>→ Parametric</a:t>
+              <a:t>Requirements</a:t>
             </a:r>
             <a:endParaRPr b="0" i="0" sz="1400" u="none" cap="none" strike="noStrike">
               <a:solidFill>
@@ -5178,7 +5178,47 @@
                 <a:cs typeface="Calibri"/>
                 <a:sym typeface="Calibri"/>
               </a:rPr>
-              <a:t>Design Intent</a:t>
+              <a:t>into a Design</a:t>
+            </a:r>
+            <a:endParaRPr b="0" i="0" sz="1400" u="none" cap="none" strike="noStrike">
+              <a:solidFill>
+                <a:schemeClr val="dk1"/>
+              </a:solidFill>
+              <a:latin typeface="Calibri"/>
+              <a:ea typeface="Calibri"/>
+              <a:cs typeface="Calibri"/>
+              <a:sym typeface="Calibri"/>
+            </a:endParaRPr>
+          </a:p>
+          <a:p>
+            <a:pPr indent="0" lvl="0" marL="0" marR="0" rtl="0" algn="ctr">
+              <a:lnSpc>
+                <a:spcPct val="100000"/>
+              </a:lnSpc>
+              <a:spcBef>
+                <a:spcPts val="0"/>
+              </a:spcBef>
+              <a:spcAft>
+                <a:spcPts val="0"/>
+              </a:spcAft>
+              <a:buClr>
+                <a:srgbClr val="15282D"/>
+              </a:buClr>
+              <a:buSzPts val="800"/>
+              <a:buFont typeface="Calibri"/>
+              <a:buNone/>
+            </a:pPr>
+            <a:r>
+              <a:rPr b="1" i="0" lang="en-US" sz="1400" u="none" cap="none" strike="noStrike">
+                <a:solidFill>
+                  <a:srgbClr val="15282D"/>
+                </a:solidFill>
+                <a:latin typeface="Calibri"/>
+                <a:ea typeface="Calibri"/>
+                <a:cs typeface="Calibri"/>
+                <a:sym typeface="Calibri"/>
+              </a:rPr>
+              <a:t>Plan</a:t>
             </a:r>
             <a:endParaRPr b="0" i="0" sz="1400" u="none" cap="none" strike="noStrike">
               <a:solidFill>
@@ -5295,7 +5335,7 @@
                 <a:cs typeface="Calibri"/>
                 <a:sym typeface="Calibri"/>
               </a:rPr>
-              <a:t>Parameter Set</a:t>
+              <a:t>Generate a</a:t>
             </a:r>
             <a:endParaRPr b="0" i="0" sz="1400" u="none" cap="none" strike="noStrike">
               <a:solidFill>
@@ -5335,7 +5375,7 @@
                 <a:cs typeface="Calibri"/>
                 <a:sym typeface="Calibri"/>
               </a:rPr>
-              <a:t>Generation</a:t>
+              <a:t>Parameter Set</a:t>
             </a:r>
             <a:endParaRPr b="0" i="0" sz="1400" u="none" cap="none" strike="noStrike">
               <a:solidFill>
@@ -5452,7 +5492,7 @@
                 <a:cs typeface="Calibri"/>
                 <a:sym typeface="Calibri"/>
               </a:rPr>
-              <a:t>FreeCAD Layer</a:t>
+              <a:t>FreeCAD Builds</a:t>
             </a:r>
             <a:endParaRPr b="0" i="0" sz="1400" u="none" cap="none" strike="noStrike">
               <a:solidFill>
@@ -5492,7 +5532,7 @@
                 <a:cs typeface="Calibri"/>
                 <a:sym typeface="Calibri"/>
               </a:rPr>
-              <a:t>MCP Toolchain</a:t>
+              <a:t>the Model</a:t>
             </a:r>
             <a:endParaRPr b="0" i="0" sz="1400" u="none" cap="none" strike="noStrike">
               <a:solidFill>
@@ -5532,7 +5572,47 @@
                 <a:cs typeface="Calibri"/>
                 <a:sym typeface="Calibri"/>
               </a:rPr>
-              <a:t>+ Scripts</a:t>
+              <a:t>(MCP Tools</a:t>
+            </a:r>
+            <a:endParaRPr b="0" i="0" sz="1400" u="none" cap="none" strike="noStrike">
+              <a:solidFill>
+                <a:schemeClr val="dk1"/>
+              </a:solidFill>
+              <a:latin typeface="Calibri"/>
+              <a:ea typeface="Calibri"/>
+              <a:cs typeface="Calibri"/>
+              <a:sym typeface="Calibri"/>
+            </a:endParaRPr>
+          </a:p>
+          <a:p>
+            <a:pPr indent="0" lvl="0" marL="0" marR="0" rtl="0" algn="ctr">
+              <a:lnSpc>
+                <a:spcPct val="100000"/>
+              </a:lnSpc>
+              <a:spcBef>
+                <a:spcPts val="0"/>
+              </a:spcBef>
+              <a:spcAft>
+                <a:spcPts val="0"/>
+              </a:spcAft>
+              <a:buClr>
+                <a:srgbClr val="15282D"/>
+              </a:buClr>
+              <a:buSzPts val="780"/>
+              <a:buFont typeface="Calibri"/>
+              <a:buNone/>
+            </a:pPr>
+            <a:r>
+              <a:rPr b="0" i="0" lang="en-US" sz="1400" u="none" cap="none" strike="noStrike">
+                <a:solidFill>
+                  <a:srgbClr val="15282D"/>
+                </a:solidFill>
+                <a:latin typeface="Calibri"/>
+                <a:ea typeface="Calibri"/>
+                <a:cs typeface="Calibri"/>
+                <a:sym typeface="Calibri"/>
+              </a:rPr>
+              <a:t>and Scripts)</a:t>
             </a:r>
             <a:endParaRPr b="0" i="0" sz="1400" u="none" cap="none" strike="noStrike">
               <a:solidFill>
@@ -5689,7 +5769,7 @@
                 <a:cs typeface="Calibri"/>
                 <a:sym typeface="Calibri"/>
               </a:rPr>
-              <a:t>STL / STEP</a:t>
+              <a:t>as STL, STEP</a:t>
             </a:r>
             <a:endParaRPr b="0" i="0" sz="1400" u="none" cap="none" strike="noStrike">
               <a:solidFill>
@@ -5729,7 +5809,7 @@
                 <a:cs typeface="Calibri"/>
                 <a:sym typeface="Calibri"/>
               </a:rPr>
-              <a:t>FCStd</a:t>
+              <a:t>or FCStd</a:t>
             </a:r>
             <a:endParaRPr b="0" i="0" sz="1400" u="none" cap="none" strike="noStrike">
               <a:solidFill>
@@ -5846,7 +5926,7 @@
                 <a:cs typeface="Calibri"/>
                 <a:sym typeface="Calibri"/>
               </a:rPr>
-              <a:t>Automated</a:t>
+              <a:t>Automatic</a:t>
             </a:r>
             <a:endParaRPr b="0" i="0" sz="1400" u="none" cap="none" strike="noStrike">
               <a:solidFill>
@@ -5886,7 +5966,7 @@
                 <a:cs typeface="Calibri"/>
                 <a:sym typeface="Calibri"/>
               </a:rPr>
-              <a:t>Geometric</a:t>
+              <a:t>Geometry</a:t>
             </a:r>
             <a:endParaRPr b="0" i="0" sz="1400" u="none" cap="none" strike="noStrike">
               <a:solidFill>
@@ -5926,7 +6006,7 @@
                 <a:cs typeface="Calibri"/>
                 <a:sym typeface="Calibri"/>
               </a:rPr>
-              <a:t>Inspection</a:t>
+              <a:t>Check</a:t>
             </a:r>
             <a:endParaRPr b="0" i="0" sz="1400" u="none" cap="none" strike="noStrike">
               <a:solidFill>
@@ -6041,7 +6121,7 @@
                 <a:cs typeface="Calibri"/>
                 <a:sym typeface="Calibri"/>
               </a:rPr>
-              <a:t>Divergence</a:t>
+              <a:t>Decision</a:t>
             </a:r>
             <a:endParaRPr b="0" i="0" sz="1400" u="none" cap="none" strike="noStrike">
               <a:solidFill>
@@ -6967,7 +7047,7 @@
                 <a:cs typeface="Calibri"/>
                 <a:sym typeface="Calibri"/>
               </a:rPr>
-              <a:t>Expert Selection</a:t>
+              <a:t>An Expert Picks</a:t>
             </a:r>
             <a:endParaRPr b="0" i="0" sz="1400" u="none" cap="none" strike="noStrike">
               <a:solidFill>
@@ -7007,7 +7087,7 @@
                 <a:cs typeface="Calibri"/>
                 <a:sym typeface="Calibri"/>
               </a:rPr>
-              <a:t>Chosen Prototype</a:t>
+              <a:t>the Prototype</a:t>
             </a:r>
             <a:endParaRPr b="0" i="0" sz="1400" u="none" cap="none" strike="noStrike">
               <a:solidFill>
@@ -7388,46 +7468,6 @@
                 <a:cs typeface="Calibri"/>
                 <a:sym typeface="Calibri"/>
               </a:rPr>
-              <a:t>Emulator Layer</a:t>
-            </a:r>
-            <a:endParaRPr b="0" i="0" sz="1400" u="none" cap="none" strike="noStrike">
-              <a:solidFill>
-                <a:schemeClr val="dk1"/>
-              </a:solidFill>
-              <a:latin typeface="Calibri"/>
-              <a:ea typeface="Calibri"/>
-              <a:cs typeface="Calibri"/>
-              <a:sym typeface="Calibri"/>
-            </a:endParaRPr>
-          </a:p>
-          <a:p>
-            <a:pPr indent="0" lvl="0" marL="0" marR="0" rtl="0" algn="ctr">
-              <a:lnSpc>
-                <a:spcPct val="100000"/>
-              </a:lnSpc>
-              <a:spcBef>
-                <a:spcPts val="0"/>
-              </a:spcBef>
-              <a:spcAft>
-                <a:spcPts val="0"/>
-              </a:spcAft>
-              <a:buClr>
-                <a:srgbClr val="15282D"/>
-              </a:buClr>
-              <a:buSzPts val="720"/>
-              <a:buFont typeface="Calibri"/>
-              <a:buNone/>
-            </a:pPr>
-            <a:r>
-              <a:rPr b="1" i="0" lang="en-US" sz="1400" u="none" cap="none" strike="noStrike">
-                <a:solidFill>
-                  <a:srgbClr val="15282D"/>
-                </a:solidFill>
-                <a:latin typeface="Calibri"/>
-                <a:ea typeface="Calibri"/>
-                <a:cs typeface="Calibri"/>
-                <a:sym typeface="Calibri"/>
-              </a:rPr>
               <a:t>Acoustic</a:t>
             </a:r>
             <a:endParaRPr b="0" i="0" sz="1400" u="none" cap="none" strike="noStrike">
@@ -7508,7 +7548,7 @@
                 <a:cs typeface="Calibri"/>
                 <a:sym typeface="Calibri"/>
               </a:rPr>
-              <a:t>FEM / BEM</a:t>
+              <a:t>(FEM / BEM,</a:t>
             </a:r>
             <a:endParaRPr b="0" i="0" sz="1400" u="none" cap="none" strike="noStrike">
               <a:solidFill>
@@ -7548,7 +7588,47 @@
                 <a:cs typeface="Calibri"/>
                 <a:sym typeface="Calibri"/>
               </a:rPr>
-              <a:t>(extensible)</a:t>
+              <a:t>other tools</a:t>
+            </a:r>
+            <a:endParaRPr b="0" i="0" sz="1400" u="none" cap="none" strike="noStrike">
+              <a:solidFill>
+                <a:schemeClr val="dk1"/>
+              </a:solidFill>
+              <a:latin typeface="Calibri"/>
+              <a:ea typeface="Calibri"/>
+              <a:cs typeface="Calibri"/>
+              <a:sym typeface="Calibri"/>
+            </a:endParaRPr>
+          </a:p>
+          <a:p>
+            <a:pPr indent="0" lvl="0" marL="0" marR="0" rtl="0" algn="ctr">
+              <a:lnSpc>
+                <a:spcPct val="100000"/>
+              </a:lnSpc>
+              <a:spcBef>
+                <a:spcPts val="0"/>
+              </a:spcBef>
+              <a:spcAft>
+                <a:spcPts val="0"/>
+              </a:spcAft>
+              <a:buClr>
+                <a:srgbClr val="15282D"/>
+              </a:buClr>
+              <a:buSzPts val="720"/>
+              <a:buFont typeface="Calibri"/>
+              <a:buNone/>
+            </a:pPr>
+            <a:r>
+              <a:rPr b="1" i="0" lang="en-US" sz="1400" u="none" cap="none" strike="noStrike">
+                <a:solidFill>
+                  <a:srgbClr val="15282D"/>
+                </a:solidFill>
+                <a:latin typeface="Calibri"/>
+                <a:ea typeface="Calibri"/>
+                <a:cs typeface="Calibri"/>
+                <a:sym typeface="Calibri"/>
+              </a:rPr>
+              <a:t>can be added)</a:t>
             </a:r>
             <a:endParaRPr b="0" i="0" sz="1400" u="none" cap="none" strike="noStrike">
               <a:solidFill>
@@ -7705,7 +7785,7 @@
                 <a:cs typeface="Calibri"/>
                 <a:sym typeface="Calibri"/>
               </a:rPr>
-              <a:t>Results →</a:t>
+              <a:t>Results as</a:t>
             </a:r>
             <a:endParaRPr b="0" i="0" sz="1400" u="none" cap="none" strike="noStrike">
               <a:solidFill>
@@ -7745,47 +7825,7 @@
                 <a:cs typeface="Calibri"/>
                 <a:sym typeface="Calibri"/>
               </a:rPr>
-              <a:t>Quantitative</a:t>
-            </a:r>
-            <a:endParaRPr b="0" i="0" sz="1400" u="none" cap="none" strike="noStrike">
-              <a:solidFill>
-                <a:schemeClr val="dk1"/>
-              </a:solidFill>
-              <a:latin typeface="Calibri"/>
-              <a:ea typeface="Calibri"/>
-              <a:cs typeface="Calibri"/>
-              <a:sym typeface="Calibri"/>
-            </a:endParaRPr>
-          </a:p>
-          <a:p>
-            <a:pPr indent="0" lvl="0" marL="0" marR="0" rtl="0" algn="ctr">
-              <a:lnSpc>
-                <a:spcPct val="100000"/>
-              </a:lnSpc>
-              <a:spcBef>
-                <a:spcPts val="0"/>
-              </a:spcBef>
-              <a:spcAft>
-                <a:spcPts val="0"/>
-              </a:spcAft>
-              <a:buClr>
-                <a:srgbClr val="15282D"/>
-              </a:buClr>
-              <a:buSzPts val="800"/>
-              <a:buFont typeface="Calibri"/>
-              <a:buNone/>
-            </a:pPr>
-            <a:r>
-              <a:rPr b="0" i="0" lang="en-US" sz="1400" u="none" cap="none" strike="noStrike">
-                <a:solidFill>
-                  <a:srgbClr val="15282D"/>
-                </a:solidFill>
-                <a:latin typeface="Calibri"/>
-                <a:ea typeface="Calibri"/>
-                <a:cs typeface="Calibri"/>
-                <a:sym typeface="Calibri"/>
-              </a:rPr>
-              <a:t>Metrics</a:t>
+              <a:t>Numbers</a:t>
             </a:r>
             <a:endParaRPr b="0" i="0" sz="1400" u="none" cap="none" strike="noStrike">
               <a:solidFill>
@@ -7902,7 +7942,7 @@
                 <a:cs typeface="Calibri"/>
                 <a:sym typeface="Calibri"/>
               </a:rPr>
-              <a:t>Agent</a:t>
+              <a:t>Agent Compares</a:t>
             </a:r>
             <a:endParaRPr b="0" i="0" sz="1400" u="none" cap="none" strike="noStrike">
               <a:solidFill>
@@ -7942,7 +7982,7 @@
                 <a:cs typeface="Calibri"/>
                 <a:sym typeface="Calibri"/>
               </a:rPr>
-              <a:t>Interpretation</a:t>
+              <a:t>Results with</a:t>
             </a:r>
             <a:endParaRPr b="0" i="0" sz="1400" u="none" cap="none" strike="noStrike">
               <a:solidFill>
@@ -7982,7 +8022,7 @@
                 <a:cs typeface="Calibri"/>
                 <a:sym typeface="Calibri"/>
               </a:rPr>
-              <a:t>Compare Against</a:t>
+              <a:t>the Targets and</a:t>
             </a:r>
             <a:endParaRPr b="0" i="0" sz="1400" u="none" cap="none" strike="noStrike">
               <a:solidFill>
@@ -8022,7 +8062,7 @@
                 <a:cs typeface="Calibri"/>
                 <a:sym typeface="Calibri"/>
               </a:rPr>
-              <a:t>Design Targets</a:t>
+              <a:t>Finds the</a:t>
             </a:r>
             <a:endParaRPr b="0" i="0" sz="1400" u="none" cap="none" strike="noStrike">
               <a:solidFill>
@@ -8062,7 +8102,7 @@
                 <a:cs typeface="Calibri"/>
                 <a:sym typeface="Calibri"/>
               </a:rPr>
-              <a:t>Find Failures</a:t>
+              <a:t>Causes</a:t>
             </a:r>
             <a:endParaRPr b="0" i="0" sz="1400" u="none" cap="none" strike="noStrike">
               <a:solidFill>
@@ -9116,7 +9156,7 @@
                 <a:cs typeface="Calibri"/>
                 <a:sym typeface="Calibri"/>
               </a:rPr>
-              <a:t>Fail, send back</a:t>
+              <a:t>Fail: send back</a:t>
             </a:r>
             <a:endParaRPr b="0" i="0" sz="1400" u="none" cap="none" strike="noStrike">
               <a:solidFill>
@@ -9380,7 +9420,7 @@
                 <a:cs typeface="Calibri"/>
                 <a:sym typeface="Calibri"/>
               </a:rPr>
-              <a:t>No: next iteration</a:t>
+              <a:t>No: run again</a:t>
             </a:r>
             <a:endParaRPr b="0" i="0" sz="1400" u="none" cap="none" strike="noStrike">
               <a:solidFill>
@@ -9497,7 +9537,7 @@
                 <a:cs typeface="Calibri"/>
                 <a:sym typeface="Calibri"/>
               </a:rPr>
-              <a:t>Two ways out of the Divergence Point</a:t>
+              <a:t>Two ways out of the Decision Point</a:t>
             </a:r>
             <a:endParaRPr b="0" i="0" sz="1400" u="none" cap="none" strike="noStrike">
               <a:solidFill>
@@ -9563,7 +9603,7 @@
                 <a:cs typeface="Calibri"/>
                 <a:sym typeface="Calibri"/>
               </a:rPr>
-              <a:t>Path 1 — human in the loop:</a:t>
+              <a:t>Path 1 — expert decides:</a:t>
             </a:r>
             <a:endParaRPr b="0" i="0" sz="1400" u="none" cap="none" strike="noStrike">
               <a:solidFill>
@@ -9629,7 +9669,7 @@
                 <a:cs typeface="Calibri"/>
                 <a:sym typeface="Calibri"/>
               </a:rPr>
-              <a:t>an expert picks a prototype.</a:t>
+              <a:t>an expert picks one prototype.</a:t>
             </a:r>
             <a:endParaRPr b="0" i="0" sz="1400" u="none" cap="none" strike="noStrike">
               <a:solidFill>
@@ -9695,7 +9735,7 @@
                 <a:cs typeface="Calibri"/>
                 <a:sym typeface="Calibri"/>
               </a:rPr>
-              <a:t>Path 2 — simulate and iterate:</a:t>
+              <a:t>Path 2 — simulate and repeat:</a:t>
             </a:r>
             <a:endParaRPr b="0" i="0" sz="1400" u="none" cap="none" strike="noStrike">
               <a:solidFill>
@@ -9761,7 +9801,7 @@
                 <a:cs typeface="Calibri"/>
                 <a:sym typeface="Calibri"/>
               </a:rPr>
-              <a:t>agent reads metrics, loop decides.</a:t>
+              <a:t>the agent checks the results.</a:t>
             </a:r>
             <a:endParaRPr b="0" i="0" sz="1400" u="none" cap="none" strike="noStrike">
               <a:solidFill>
@@ -9827,7 +9867,7 @@
                 <a:cs typeface="Calibri"/>
                 <a:sym typeface="Calibri"/>
               </a:rPr>
-              <a:t>Both feedback edges return to Parameter Set Generation. That is the only re-entry point.</a:t>
+              <a:t>Both feedback paths go back to Generate a Parameter Set. That is the only way back in.</a:t>
             </a:r>
             <a:endParaRPr b="0" i="0" sz="1400" u="none" cap="none" strike="noStrike">
               <a:solidFill>
@@ -10010,7 +10050,7 @@
                 <a:cs typeface="Calibri"/>
                 <a:sym typeface="Calibri"/>
               </a:rPr>
-              <a:t>Scan evidence also feeds the priors: product scans → benchmarks; combined scans → real wearing relationship.</a:t>
+              <a:t>Scan data also updates the prior knowledge: product scans → market products; ear mold scans → real wearing data.</a:t>
             </a:r>
             <a:endParaRPr b="0" i="0" sz="1400" u="none" cap="none" strike="noStrike">
               <a:solidFill>
@@ -10277,7 +10317,7 @@
                 <a:cs typeface="Calibri"/>
                 <a:sym typeface="Calibri"/>
               </a:rPr>
-              <a:t>Converged Delivery</a:t>
+              <a:t>Final Model</a:t>
             </a:r>
             <a:endParaRPr b="0" i="0" sz="1400" u="none" cap="none" strike="noStrike">
               <a:solidFill>
@@ -10317,7 +10357,7 @@
                 <a:cs typeface="Calibri"/>
                 <a:sym typeface="Calibri"/>
               </a:rPr>
-              <a:t>Model + Full</a:t>
+              <a:t>+ Full Record</a:t>
             </a:r>
             <a:endParaRPr b="0" i="0" sz="1400" u="none" cap="none" strike="noStrike">
               <a:solidFill>
@@ -10357,7 +10397,7 @@
                 <a:cs typeface="Calibri"/>
                 <a:sym typeface="Calibri"/>
               </a:rPr>
-              <a:t>Traceability Chain</a:t>
+              <a:t>of All Steps</a:t>
             </a:r>
             <a:endParaRPr b="0" i="0" sz="1400" u="none" cap="none" strike="noStrike">
               <a:solidFill>
@@ -10474,7 +10514,7 @@
                 <a:cs typeface="Calibri"/>
                 <a:sym typeface="Calibri"/>
               </a:rPr>
-              <a:t>3D scan evidence</a:t>
+              <a:t>3D scan data</a:t>
             </a:r>
             <a:endParaRPr b="0" i="0" sz="1400" u="none" cap="none" strike="noStrike">
               <a:solidFill>
@@ -10708,7 +10748,7 @@
                 <a:cs typeface="Calibri"/>
                 <a:sym typeface="Calibri"/>
               </a:rPr>
-              <a:t>agent / tooling</a:t>
+              <a:t>agent and tools</a:t>
             </a:r>
             <a:endParaRPr b="0" i="0" sz="1400" u="none" cap="none" strike="noStrike">
               <a:solidFill>
@@ -10825,7 +10865,7 @@
                 <a:cs typeface="Calibri"/>
                 <a:sym typeface="Calibri"/>
               </a:rPr>
-              <a:t>decision &amp; feedback</a:t>
+              <a:t>feedback paths</a:t>
             </a:r>
             <a:endParaRPr b="0" i="0" sz="1400" u="none" cap="none" strike="noStrike">
               <a:solidFill>
@@ -10942,7 +10982,7 @@
                 <a:cs typeface="Calibri"/>
                 <a:sym typeface="Calibri"/>
               </a:rPr>
-              <a:t>human in the loop</a:t>
+              <a:t>expert decision</a:t>
             </a:r>
             <a:endParaRPr b="0" i="0" sz="1400" u="none" cap="none" strike="noStrike">
               <a:solidFill>
@@ -11059,7 +11099,7 @@
                 <a:cs typeface="Calibri"/>
                 <a:sym typeface="Calibri"/>
               </a:rPr>
-              <a:t>converged output</a:t>
+              <a:t>final output</a:t>
             </a:r>
             <a:endParaRPr b="0" i="0" sz="1400" u="none" cap="none" strike="noStrike">
               <a:solidFill>

</xml_diff>